<commit_message>
Update poster and abstract: contact emails of all three authors
</commit_message>
<xml_diff>
--- a/docs/Poster_FrozenDINOv3MartianTerrain.pptx
+++ b/docs/Poster_FrozenDINOv3MartianTerrain.pptx
@@ -3409,7 +3409,7 @@
                 </a:solidFill>
                 <a:latin typeface="Arial"/>
               </a:rPr>
-              <a:t>¹Pontificia Universidad Católica del Perú, Lima, Peru   ·   gquispeo@pucp.edu.pe</a:t>
+              <a:t>¹Pontificia Universidad Católica del Perú, Lima, Peru   ·   gquispeo@pucp.edu.pe · meza.gustavo@pucp.edu.pe · david.rodriguezc@pucp.edu.pe</a:t>
             </a:r>
           </a:p>
         </p:txBody>
@@ -6018,7 +6018,7 @@
                 </a:solidFill>
                 <a:latin typeface="Arial"/>
               </a:rPr>
-              <a:t>gquispeo@pucp.edu.pe</a:t>
+              <a:t>gquispeo@pucp.edu.pe · meza.gustavo@pucp.edu.pe · david.rodriguezc@pucp.edu.pe</a:t>
             </a:r>
           </a:p>
           <a:p>

</xml_diff>

<commit_message>
Address review: fix majority-class numbers, cite Goh et al., soften random-init claim, name supported hypothesis (H4), simplify poster
</commit_message>
<xml_diff>
--- a/docs/Poster_FrozenDINOv3MartianTerrain.pptx
+++ b/docs/Poster_FrozenDINOv3MartianTerrain.pptx
@@ -3708,7 +3708,7 @@
               </a:spcAft>
             </a:pPr>
             <a:r>
-              <a:rPr sz="2400" b="0" i="0">
+              <a:rPr sz="3000" b="0" i="0">
                 <a:solidFill>
                   <a:srgbClr val="28282D"/>
                 </a:solidFill>
@@ -3724,7 +3724,7 @@
               </a:spcAft>
             </a:pPr>
             <a:r>
-              <a:rPr sz="2400" b="0" i="0">
+              <a:rPr sz="3000" b="0" i="0">
                 <a:solidFill>
                   <a:srgbClr val="28282D"/>
                 </a:solidFill>
@@ -3740,7 +3740,7 @@
               </a:spcAft>
             </a:pPr>
             <a:r>
-              <a:rPr sz="2400" b="1" i="0">
+              <a:rPr sz="3000" b="1" i="0">
                 <a:solidFill>
                   <a:srgbClr val="28282D"/>
                 </a:solidFill>
@@ -3749,7 +3749,7 @@
               <a:t>• Question: </a:t>
             </a:r>
             <a:r>
-              <a:rPr sz="2400" b="0" i="0">
+              <a:rPr sz="3000" b="0" i="0">
                 <a:solidFill>
                   <a:srgbClr val="28282D"/>
                 </a:solidFill>
@@ -3912,13 +3912,22 @@
               </a:spcAft>
             </a:pPr>
             <a:r>
-              <a:rPr sz="2400" b="0" i="0">
+              <a:rPr sz="3000" b="1" i="0">
                 <a:solidFill>
                   <a:srgbClr val="28282D"/>
                 </a:solidFill>
                 <a:latin typeface="Arial"/>
               </a:rPr>
-              <a:t>• Measure the transfer of frozen DINOv3 ViT-B/16 to AI4Mars (Curiosity): layer-wise linear probe (4,612 trainable parameters), then a larger decoder and partial fine-tuning.</a:t>
+              <a:t>• Study: </a:t>
+            </a:r>
+            <a:r>
+              <a:rPr sz="3000" b="0" i="0">
+                <a:solidFill>
+                  <a:srgbClr val="28282D"/>
+                </a:solidFill>
+                <a:latin typeface="Arial"/>
+              </a:rPr>
+              <a:t>off-the-shelf frozen DINOv3 ViT-B/16 on AI4Mars (Curiosity), 4 terrain classes.</a:t>
             </a:r>
           </a:p>
           <a:p>
@@ -3928,13 +3937,22 @@
               </a:spcAft>
             </a:pPr>
             <a:r>
-              <a:rPr sz="2400" b="0" i="0">
+              <a:rPr sz="3000" b="1" i="0">
                 <a:solidFill>
                   <a:srgbClr val="28282D"/>
                 </a:solidFill>
                 <a:latin typeface="Arial"/>
               </a:rPr>
-              <a:t>• Uncertainty: 3 seeds and bootstrap confidence intervals over images; six hypotheses and decision rules fixed before the final run.</a:t>
+              <a:t>• Approach: </a:t>
+            </a:r>
+            <a:r>
+              <a:rPr sz="3000" b="0" i="0">
+                <a:solidFill>
+                  <a:srgbClr val="28282D"/>
+                </a:solidFill>
+                <a:latin typeface="Arial"/>
+              </a:rPr>
+              <a:t>one linear probe per layer (4.6 k parameters), then a decoder and partial fine-tuning; 3 seeds, bootstrap CIs.</a:t>
             </a:r>
           </a:p>
           <a:p>
@@ -3944,29 +3962,22 @@
               </a:spcAft>
             </a:pPr>
             <a:r>
-              <a:rPr sz="2400" b="0" i="0">
+              <a:rPr sz="3000" b="1" i="0">
                 <a:solidFill>
                   <a:srgbClr val="28282D"/>
                 </a:solidFill>
                 <a:latin typeface="Arial"/>
               </a:rPr>
-              <a:t>• Controls: random-init ViT, DINOv2, label efficiency, label-border noise and published baselines (M1–M3).</a:t>
-            </a:r>
-          </a:p>
-          <a:p>
-            <a:pPr algn="l">
-              <a:spcAft>
-                <a:spcPts val="992"/>
-              </a:spcAft>
-            </a:pPr>
-            <a:r>
-              <a:rPr sz="2400" b="0" i="0">
+              <a:t>• Related: </a:t>
+            </a:r>
+            <a:r>
+              <a:rPr sz="3000" b="0" i="0">
                 <a:solidFill>
                   <a:srgbClr val="28282D"/>
                 </a:solidFill>
                 <a:latin typeface="Arial"/>
               </a:rPr>
-              <a:t>• None of the seven AI4Mars baseline papers we reviewed uses a frozen foundation backbone (MANTLE [7] does, for binary boulder segmentation on its own MSL data).</a:t>
+              <a:t>Goh et al. [6] pretrain their own backbone with few labels; MANTLE [7] freezes one for binary boulders. We freeze a web-pretrained backbone for 4 terrain classes.</a:t>
             </a:r>
           </a:p>
         </p:txBody>
@@ -4147,7 +4158,7 @@
               </a:spcAft>
             </a:pPr>
             <a:r>
-              <a:rPr sz="2400" b="1" i="0">
+              <a:rPr sz="3000" b="1" i="0">
                 <a:solidFill>
                   <a:srgbClr val="28282D"/>
                 </a:solidFill>
@@ -4156,13 +4167,13 @@
               <a:t>• Data: </a:t>
             </a:r>
             <a:r>
-              <a:rPr sz="2400" b="0" i="0">
+              <a:rPr sz="3000" b="0" i="0">
                 <a:solidFill>
                   <a:srgbClr val="28282D"/>
                 </a:solidFill>
                 <a:latin typeface="Arial"/>
               </a:rPr>
-              <a:t>AI4Mars, Curiosity NavCam, 512×512 px. 15,564 training images (crowd labels), 500 validation (temporal hold-out), 322 expert test images in three variants M1 / M2 / M3, scored at native label resolution.</a:t>
+              <a:t>AI4Mars, 512 px; 15,564 train, 500 validation (temporal hold-out), 322 expert test images (M1, M2, M3).</a:t>
             </a:r>
           </a:p>
           <a:p>
@@ -4172,7 +4183,7 @@
               </a:spcAft>
             </a:pPr>
             <a:r>
-              <a:rPr sz="2400" b="1" i="0">
+              <a:rPr sz="3000" b="1" i="0">
                 <a:solidFill>
                   <a:srgbClr val="28282D"/>
                 </a:solidFill>
@@ -4181,13 +4192,13 @@
               <a:t>• Model: </a:t>
             </a:r>
             <a:r>
-              <a:rPr sz="2400" b="0" i="0">
+              <a:rPr sz="3000" b="0" i="0">
                 <a:solidFill>
                   <a:srgbClr val="28282D"/>
                 </a:solidFill>
                 <a:latin typeface="Arial"/>
               </a:rPr>
-              <a:t>DINOv3 ViT-B/16, frozen; features read at blocks 2, 4, 6, 8, 10, 12 and the final norm.</a:t>
+              <a:t>frozen DINOv3 ViT-B/16; probe per layer (4.6 k), decoder (3.5 M), last 2 / 4 blocks fine-tuned (14 M / 28 M).</a:t>
             </a:r>
           </a:p>
           <a:p>
@@ -4197,47 +4208,22 @@
               </a:spcAft>
             </a:pPr>
             <a:r>
-              <a:rPr sz="2400" b="1" i="0">
+              <a:rPr sz="3000" b="1" i="0">
                 <a:solidFill>
                   <a:srgbClr val="28282D"/>
                 </a:solidFill>
                 <a:latin typeface="Arial"/>
               </a:rPr>
-              <a:t>• Heads: </a:t>
-            </a:r>
-            <a:r>
-              <a:rPr sz="2400" b="0" i="0">
+              <a:t>• Evaluation: </a:t>
+            </a:r>
+            <a:r>
+              <a:rPr sz="3000" b="0" i="0">
                 <a:solidFill>
                   <a:srgbClr val="28282D"/>
                 </a:solidFill>
                 <a:latin typeface="Arial"/>
               </a:rPr>
-              <a:t>linear probe (BatchNorm + 1×1 conv, 4.6 k parameters) per layer; decoder fusing blocks 3, 6, 9 and 12 (3.5 M); last 2 or 4 blocks fine-tuned (14 M / 28 M). 3 seeds each.</a:t>
-            </a:r>
-          </a:p>
-          <a:p>
-            <a:pPr algn="l">
-              <a:spcAft>
-                <a:spcPts val="992"/>
-              </a:spcAft>
-            </a:pPr>
-            <a:r>
-              <a:rPr sz="2400" b="1" i="0">
-                <a:solidFill>
-                  <a:srgbClr val="28282D"/>
-                </a:solidFill>
-                <a:latin typeface="Arial"/>
-              </a:rPr>
-              <a:t>• Evaluation: </a:t>
-            </a:r>
-            <a:r>
-              <a:rPr sz="2400" b="0" i="0">
-                <a:solidFill>
-                  <a:srgbClr val="28282D"/>
-                </a:solidFill>
-                <a:latin typeface="Arial"/>
-              </a:rPr>
-              <a:t>mIoU over 4 classes; layer and epoch chosen on validation, the test set only confirms; 95 % paired bootstrap CIs over images; a difference counts as real if its CI excludes 0 and |Δ| ≥ 0.01.</a:t>
+              <a:t>mIoU; layers chosen on validation; a gap is real if its 95 % bootstrap CI excludes 0 and |Δ| ≥ 0.01.</a:t>
             </a:r>
           </a:p>
         </p:txBody>
@@ -4394,7 +4380,7 @@
               </a:spcAft>
             </a:pPr>
             <a:r>
-              <a:rPr sz="2400" b="1" i="0">
+              <a:rPr sz="3000" b="1" i="0">
                 <a:solidFill>
                   <a:srgbClr val="28282D"/>
                 </a:solidFill>
@@ -4403,13 +4389,13 @@
               <a:t>• Big rock is the hardest class: </a:t>
             </a:r>
             <a:r>
-              <a:rPr sz="2400" b="0" i="0">
+              <a:rPr sz="3000" b="0" i="0">
                 <a:solidFill>
                   <a:srgbClr val="28282D"/>
                 </a:solidFill>
                 <a:latin typeface="Arial"/>
               </a:rPr>
-              <a:t>validation IoU 0.24 (probe) vs 0.62–0.88 for the others, and 0.13 / 0.12 on test M1 / M2; 69 % of its pixels are predicted as bedrock (probe), 60 % (decoder).</a:t>
+              <a:t>IoU 0.24 on validation (others 0.62–0.88); 69 % of it is predicted as bedrock.</a:t>
             </a:r>
           </a:p>
           <a:p>
@@ -4419,7 +4405,7 @@
               </a:spcAft>
             </a:pPr>
             <a:r>
-              <a:rPr sz="2400" b="1" i="0">
+              <a:rPr sz="3000" b="1" i="0">
                 <a:solidFill>
                   <a:srgbClr val="28282D"/>
                 </a:solidFill>
@@ -4428,13 +4414,13 @@
               <a:t>• M3 hides this: </a:t>
             </a:r>
             <a:r>
-              <a:rPr sz="2400" b="0" i="0">
+              <a:rPr sz="3000" b="0" i="0">
                 <a:solidFill>
                   <a:srgbClr val="28282D"/>
                 </a:solidFill>
                 <a:latin typeface="Arial"/>
               </a:rPr>
-              <a:t>big rock appears in only 5 of its 322 images (77,698 px). Every model finds 96–99 % of those pixels; they differ in false alarms (probe 109 k px, decoder 16 k px), which drives the M3 mIoU gap (0.83 vs 0.93). Without big rock all models reach 0.96–0.97.</a:t>
+              <a:t>only 5 of its 322 images contain big rock. Models differ in false alarms (probe 109 k px, decoder 16 k px), which drives the M3 gap (0.83 vs 0.93).</a:t>
             </a:r>
           </a:p>
           <a:p>
@@ -4444,13 +4430,22 @@
               </a:spcAft>
             </a:pPr>
             <a:r>
-              <a:rPr sz="2400" b="0" i="0">
+              <a:rPr sz="3000" b="1" i="0">
                 <a:solidFill>
                   <a:srgbClr val="28282D"/>
                 </a:solidFill>
                 <a:latin typeface="Arial"/>
               </a:rPr>
-              <a:t>• Size alone does not explain the misses: recall is 0.28 for the smallest third of big-rock regions and 0.34 for the largest (inconclusive).</a:t>
+              <a:t>• Size alone does not explain misses </a:t>
+            </a:r>
+            <a:r>
+              <a:rPr sz="3000" b="0" i="0">
+                <a:solidFill>
+                  <a:srgbClr val="28282D"/>
+                </a:solidFill>
+                <a:latin typeface="Arial"/>
+              </a:rPr>
+              <a:t>(inconclusive).</a:t>
             </a:r>
           </a:p>
         </p:txBody>
@@ -4670,7 +4665,7 @@
               </a:spcAft>
             </a:pPr>
             <a:r>
-              <a:rPr sz="2400" b="1" i="0">
+              <a:rPr sz="2800" b="1" i="0">
                 <a:solidFill>
                   <a:srgbClr val="28282D"/>
                 </a:solidFill>
@@ -4679,13 +4674,13 @@
               <a:t>• Transfer: </a:t>
             </a:r>
             <a:r>
-              <a:rPr sz="2400" b="0" i="0">
+              <a:rPr sz="2800" b="0" i="0">
                 <a:solidFill>
                   <a:srgbClr val="28282D"/>
                 </a:solidFill>
                 <a:latin typeface="Arial"/>
               </a:rPr>
-              <a:t>a linear probe on the final layer reaches mIoU 0.677 / 0.725 on test M1 / M2 (0.651 on validation; 0.125 for always predicting the majority class).</a:t>
+              <a:t>final-layer probe reaches mIoU 0.677 / 0.725 on test M1 / M2 (majority class: 0.115 / 0.123).</a:t>
             </a:r>
           </a:p>
           <a:p>
@@ -4695,7 +4690,7 @@
               </a:spcAft>
             </a:pPr>
             <a:r>
-              <a:rPr sz="2400" b="1" i="0">
+              <a:rPr sz="2800" b="1" i="0">
                 <a:solidFill>
                   <a:srgbClr val="28282D"/>
                 </a:solidFill>
@@ -4704,13 +4699,13 @@
               <a:t>• Heavier heads add little: </a:t>
             </a:r>
             <a:r>
-              <a:rPr sz="2400" b="0" i="0">
+              <a:rPr sz="2800" b="0" i="0">
                 <a:solidFill>
                   <a:srgbClr val="28282D"/>
                 </a:solidFill>
                 <a:latin typeface="Arial"/>
               </a:rPr>
-              <a:t>decoder 0.684 / 0.735, last 4 blocks fine-tuned 0.687 / 0.737 — at most +0.012 over the probe (decoder minus probe on M1: +0.007, 95 % CI [−0.001, +0.019]).</a:t>
+              <a:t>decoder 0.684 / 0.735, last 4 blocks 0.687 / 0.737 (≤ +0.012).</a:t>
             </a:r>
           </a:p>
           <a:p>
@@ -4720,22 +4715,22 @@
               </a:spcAft>
             </a:pPr>
             <a:r>
-              <a:rPr sz="2400" b="1" i="0">
+              <a:rPr sz="2800" b="1" i="0">
                 <a:solidFill>
                   <a:srgbClr val="28282D"/>
                 </a:solidFill>
                 <a:latin typeface="Arial"/>
               </a:rPr>
-              <a:t>• Pretraining matters: </a:t>
-            </a:r>
-            <a:r>
-              <a:rPr sz="2400" b="0" i="0">
+              <a:t>• Pretraining: </a:t>
+            </a:r>
+            <a:r>
+              <a:rPr sz="2800" b="0" i="0">
                 <a:solidFill>
                   <a:srgbClr val="28282D"/>
                 </a:solidFill>
                 <a:latin typeface="Arial"/>
               </a:rPr>
-              <a:t>a random-init ViT-B/16 gets 0.264 on M1 (DINOv3: +0.413); DINOv2 B/14 gets 0.664 and DINOv3 is +0.013 [+0.002, +0.025] on M1 but not clearly on M2; matching the token grid (DINOv2 at 448 px) leaves the gap unchanged (+0.014 [+0.003, +0.026]).</a:t>
+              <a:t>a frozen random ViT gets 0.264, only a lower bound (no from-scratch control). DINOv3 beats DINOv2 by +0.013 on M1 (both at N = 2,000), also at a matched token grid.</a:t>
             </a:r>
           </a:p>
           <a:p>
@@ -4745,7 +4740,7 @@
               </a:spcAft>
             </a:pPr>
             <a:r>
-              <a:rPr sz="2400" b="1" i="0">
+              <a:rPr sz="2800" b="1" i="0">
                 <a:solidFill>
                   <a:srgbClr val="28282D"/>
                 </a:solidFill>
@@ -4754,13 +4749,13 @@
               <a:t>• Baselines: </a:t>
             </a:r>
             <a:r>
-              <a:rPr sz="2400" b="0" i="0">
+              <a:rPr sz="2800" b="0" i="0">
                 <a:solidFill>
                   <a:srgbClr val="28282D"/>
                 </a:solidFill>
                 <a:latin typeface="Arial"/>
               </a:rPr>
-              <a:t>the probe is level with the 512-px published models and 0.023 / 0.015 below the best (UPerNet, 1,024 px) on M1 / M2; fine-tuning the last 4 blocks is 0.013 / 0.003 below, with 0.005–28 M trainable parameters instead of 47–81 M. Indicative only: published values are single runs on another split.</a:t>
+              <a:t>0.023 / 0.015 below the best end-to-end model (indicative only), with 4.6 k instead of 58.8–81.2 M parameters.</a:t>
             </a:r>
           </a:p>
           <a:p>
@@ -4770,47 +4765,22 @@
               </a:spcAft>
             </a:pPr>
             <a:r>
-              <a:rPr sz="2400" b="1" i="0">
+              <a:rPr sz="2800" b="1" i="0">
                 <a:solidFill>
                   <a:srgbClr val="28282D"/>
                 </a:solidFill>
                 <a:latin typeface="Arial"/>
               </a:rPr>
-              <a:t>• Layers: </a:t>
-            </a:r>
-            <a:r>
-              <a:rPr sz="2400" b="0" i="0">
+              <a:t>• Layers and labels: </a:t>
+            </a:r>
+            <a:r>
+              <a:rPr sz="2800" b="0" i="0">
                 <a:solidFill>
                   <a:srgbClr val="28282D"/>
                 </a:solidFill>
                 <a:latin typeface="Arial"/>
               </a:rPr>
-              <a:t>mIoU rises with depth and block 6 already gives 98 % of the final M1 value; no intermediate layer beats the last one (block 10, best on validation: −0.010, 95 % CI [−0.021, +0.001]).</a:t>
-            </a:r>
-          </a:p>
-          <a:p>
-            <a:pPr algn="l">
-              <a:spcAft>
-                <a:spcPts val="992"/>
-              </a:spcAft>
-            </a:pPr>
-            <a:r>
-              <a:rPr sz="2400" b="1" i="0">
-                <a:solidFill>
-                  <a:srgbClr val="28282D"/>
-                </a:solidFill>
-                <a:latin typeface="Arial"/>
-              </a:rPr>
-              <a:t>• Labels and borders: </a:t>
-            </a:r>
-            <a:r>
-              <a:rPr sz="2400" b="0" i="0">
-                <a:solidFill>
-                  <a:srgbClr val="28282D"/>
-                </a:solidFill>
-                <a:latin typeface="Arial"/>
-              </a:rPr>
-              <a:t>250 images give 99 % of the 4,000-image probe mIoU on M1; excluding an 8 px band around label edges raises every head by ≈ 0.025 (probe 0.677 → 0.702), consistent with, but not proof of, label noise at borders.</a:t>
+              <a:t>no intermediate layer beats the last; 250 images give 99 % of the probe's mIoU.</a:t>
             </a:r>
           </a:p>
         </p:txBody>
@@ -5441,22 +5411,22 @@
               </a:spcAft>
             </a:pPr>
             <a:r>
-              <a:rPr sz="2400" b="1" i="0">
+              <a:rPr sz="3000" b="1" i="0">
                 <a:solidFill>
                   <a:srgbClr val="28282D"/>
                 </a:solidFill>
                 <a:latin typeface="Arial"/>
               </a:rPr>
-              <a:t>• Frozen DINOv3 features transfer to Mars </a:t>
-            </a:r>
-            <a:r>
-              <a:rPr sz="2400" b="0" i="0">
+              <a:t>• Frozen DINOv3 transfers to Mars: </a:t>
+            </a:r>
+            <a:r>
+              <a:rPr sz="3000" b="0" i="0">
                 <a:solidFill>
                   <a:srgbClr val="28282D"/>
                 </a:solidFill>
                 <a:latin typeface="Arial"/>
               </a:rPr>
-              <a:t>without adapting the backbone: a linear probe (4.6 k trainable parameters) is within 0.025 mIoU of the best published end-to-end model on M1 and M2, and heavier heads add at most 0.012.</a:t>
+              <a:t>a 4.6 k-parameter probe is within 0.025 mIoU of the best published end-to-end model on M1 / M2; heavier heads add ≤ 0.012.</a:t>
             </a:r>
           </a:p>
           <a:p>
@@ -5466,13 +5436,22 @@
               </a:spcAft>
             </a:pPr>
             <a:r>
-              <a:rPr sz="2400" b="0" i="0">
+              <a:rPr sz="3000" b="1" i="0">
                 <a:solidFill>
                   <a:srgbClr val="28282D"/>
                 </a:solidFill>
                 <a:latin typeface="Arial"/>
               </a:rPr>
-              <a:t>• The gain comes from pretraining (+0.41 over a random ViT, +0.013 over DINOv2) and the final layer is as good as any other: no intermediate layer helps.</a:t>
+              <a:t>• Pretrained features matter </a:t>
+            </a:r>
+            <a:r>
+              <a:rPr sz="3000" b="0" i="0">
+                <a:solidFill>
+                  <a:srgbClr val="28282D"/>
+                </a:solidFill>
+                <a:latin typeface="Arial"/>
+              </a:rPr>
+              <a:t>(+0.41 over a frozen random ViT, +0.013 over DINOv2); no intermediate layer helps.</a:t>
             </a:r>
           </a:p>
           <a:p>
@@ -5482,13 +5461,22 @@
               </a:spcAft>
             </a:pPr>
             <a:r>
-              <a:rPr sz="2400" b="0" i="0">
+              <a:rPr sz="3000" b="1" i="0">
                 <a:solidFill>
                   <a:srgbClr val="28282D"/>
                 </a:solidFill>
                 <a:latin typeface="Arial"/>
               </a:rPr>
-              <a:t>• M1/M2 saturate early: 250 labelled images give 99 % of the probe's mIoU, and removing label borders raises every head by ≈ 0.025, so part of the ceiling may be label noise (not conclusive).</a:t>
+              <a:t>• Limits: </a:t>
+            </a:r>
+            <a:r>
+              <a:rPr sz="3000" b="0" i="0">
+                <a:solidFill>
+                  <a:srgbClr val="28282D"/>
+                </a:solidFill>
+                <a:latin typeface="Arial"/>
+              </a:rPr>
+              <a:t>one backbone, one rover, 3 seeds; only 1 of 6 hypotheses supported (H4: a decoder does not beat the probe); no from-scratch control; M3 cannot rank models on big rock.</a:t>
             </a:r>
           </a:p>
           <a:p>
@@ -5498,47 +5486,22 @@
               </a:spcAft>
             </a:pPr>
             <a:r>
-              <a:rPr sz="2400" b="1" i="0">
+              <a:rPr sz="3000" b="1" i="0">
                 <a:solidFill>
                   <a:srgbClr val="28282D"/>
                 </a:solidFill>
                 <a:latin typeface="Arial"/>
               </a:rPr>
-              <a:t>• Limits: </a:t>
-            </a:r>
-            <a:r>
-              <a:rPr sz="2400" b="0" i="0">
+              <a:t>• Next: </a:t>
+            </a:r>
+            <a:r>
+              <a:rPr sz="3000" b="0" i="0">
                 <a:solidFill>
                   <a:srgbClr val="28282D"/>
                 </a:solidFill>
                 <a:latin typeface="Arial"/>
               </a:rPr>
-              <a:t>one backbone, one rover, 3 seeds, 322 test images per variant; only 1 of 6 pre-specified hypotheses was supported, the rest are inconclusive at this sample size; M3 cannot rank models on big rock; the baseline comparison is indicative.</a:t>
-            </a:r>
-          </a:p>
-          <a:p>
-            <a:pPr algn="l">
-              <a:spcAft>
-                <a:spcPts val="992"/>
-              </a:spcAft>
-            </a:pPr>
-            <a:r>
-              <a:rPr sz="2400" b="1" i="0">
-                <a:solidFill>
-                  <a:srgbClr val="28282D"/>
-                </a:solidFill>
-                <a:latin typeface="Arial"/>
-              </a:rPr>
-              <a:t>• Next: </a:t>
-            </a:r>
-            <a:r>
-              <a:rPr sz="2400" b="0" i="0">
-                <a:solidFill>
-                  <a:srgbClr val="28282D"/>
-                </a:solidFill>
-                <a:latin typeface="Arial"/>
-              </a:rPr>
-              <a:t>retrain a published baseline under the same protocol, other rovers or datasets, big-rock-oriented losses.</a:t>
+              <a:t>same-protocol baseline, from-scratch control, other rovers.</a:t>
             </a:r>
           </a:p>
         </p:txBody>

</xml_diff>